<commit_message>
Update Emotion pipeline Presentation.pptx
</commit_message>
<xml_diff>
--- a/Emotion pipeline Presentation.pptx
+++ b/Emotion pipeline Presentation.pptx
@@ -151,7 +151,7 @@
 <file path=ppt/charts/chart1.xml><?xml version="1.0" encoding="utf-8"?>
 <c:chartSpace xmlns:c="http://schemas.openxmlformats.org/drawingml/2006/chart" xmlns:a="http://schemas.openxmlformats.org/drawingml/2006/main" xmlns:r="http://schemas.openxmlformats.org/officeDocument/2006/relationships" xmlns:c16r2="http://schemas.microsoft.com/office/drawing/2015/06/chart">
   <c:date1904 val="0"/>
-  <c:lang val="en-US"/>
+  <c:lang val="en-GB"/>
   <c:roundedCorners val="0"/>
   <mc:AlternateContent xmlns:mc="http://schemas.openxmlformats.org/markup-compatibility/2006">
     <mc:Choice xmlns:c14="http://schemas.microsoft.com/office/drawing/2007/8/2/chart" Requires="c14">
@@ -163,6 +163,407 @@
   </mc:AlternateContent>
   <c:chart>
     <c:title>
+      <c:tx>
+        <c:rich>
+          <a:bodyPr rot="0" spcFirstLastPara="1" vertOverflow="ellipsis" vert="horz" wrap="square" anchor="ctr" anchorCtr="1"/>
+          <a:lstStyle/>
+          <a:p>
+            <a:pPr>
+              <a:defRPr sz="1995" b="1" i="0" u="none" strike="noStrike" kern="1200" cap="all" spc="100" normalizeH="0" baseline="0">
+                <a:solidFill>
+                  <a:schemeClr val="lt1"/>
+                </a:solidFill>
+                <a:latin typeface="+mn-lt"/>
+                <a:ea typeface="+mn-ea"/>
+                <a:cs typeface="+mn-cs"/>
+              </a:defRPr>
+            </a:pPr>
+            <a:r>
+              <a:rPr lang="en-US" dirty="0"/>
+              <a:t>Emotion distribution</a:t>
+            </a:r>
+          </a:p>
+        </c:rich>
+      </c:tx>
+      <c:overlay val="0"/>
+      <c:spPr>
+        <a:noFill/>
+        <a:ln>
+          <a:noFill/>
+        </a:ln>
+        <a:effectLst/>
+      </c:spPr>
+      <c:txPr>
+        <a:bodyPr rot="0" spcFirstLastPara="1" vertOverflow="ellipsis" vert="horz" wrap="square" anchor="ctr" anchorCtr="1"/>
+        <a:lstStyle/>
+        <a:p>
+          <a:pPr>
+            <a:defRPr sz="1995" b="1" i="0" u="none" strike="noStrike" kern="1200" cap="all" spc="100" normalizeH="0" baseline="0">
+              <a:solidFill>
+                <a:schemeClr val="lt1"/>
+              </a:solidFill>
+              <a:latin typeface="+mn-lt"/>
+              <a:ea typeface="+mn-ea"/>
+              <a:cs typeface="+mn-cs"/>
+            </a:defRPr>
+          </a:pPr>
+          <a:endParaRPr lang="en-US"/>
+        </a:p>
+      </c:txPr>
+    </c:title>
+    <c:autoTitleDeleted val="0"/>
+    <c:plotArea>
+      <c:layout/>
+      <c:pieChart>
+        <c:varyColors val="1"/>
+        <c:ser>
+          <c:idx val="0"/>
+          <c:order val="0"/>
+          <c:tx>
+            <c:strRef>
+              <c:f>Sheet1!$B$1</c:f>
+              <c:strCache>
+                <c:ptCount val="1"/>
+                <c:pt idx="0">
+                  <c:v>Sales</c:v>
+                </c:pt>
+              </c:strCache>
+            </c:strRef>
+          </c:tx>
+          <c:spPr>
+            <a:solidFill>
+              <a:schemeClr val="lt1"/>
+            </a:solidFill>
+            <a:ln w="19050">
+              <a:solidFill>
+                <a:schemeClr val="accent1"/>
+              </a:solidFill>
+            </a:ln>
+            <a:effectLst/>
+          </c:spPr>
+          <c:dPt>
+            <c:idx val="0"/>
+            <c:bubble3D val="0"/>
+            <c:spPr>
+              <a:solidFill>
+                <a:schemeClr val="lt1"/>
+              </a:solidFill>
+              <a:ln w="19050">
+                <a:solidFill>
+                  <a:schemeClr val="accent1"/>
+                </a:solidFill>
+              </a:ln>
+              <a:effectLst/>
+            </c:spPr>
+          </c:dPt>
+          <c:dPt>
+            <c:idx val="1"/>
+            <c:bubble3D val="0"/>
+            <c:spPr>
+              <a:solidFill>
+                <a:schemeClr val="lt1"/>
+              </a:solidFill>
+              <a:ln w="19050">
+                <a:solidFill>
+                  <a:schemeClr val="accent1"/>
+                </a:solidFill>
+              </a:ln>
+              <a:effectLst/>
+            </c:spPr>
+          </c:dPt>
+          <c:dPt>
+            <c:idx val="2"/>
+            <c:bubble3D val="0"/>
+            <c:spPr>
+              <a:solidFill>
+                <a:schemeClr val="lt1"/>
+              </a:solidFill>
+              <a:ln w="19050">
+                <a:solidFill>
+                  <a:schemeClr val="accent1"/>
+                </a:solidFill>
+              </a:ln>
+              <a:effectLst/>
+            </c:spPr>
+          </c:dPt>
+          <c:dPt>
+            <c:idx val="3"/>
+            <c:bubble3D val="0"/>
+            <c:spPr>
+              <a:solidFill>
+                <a:schemeClr val="lt1"/>
+              </a:solidFill>
+              <a:ln w="19050">
+                <a:solidFill>
+                  <a:schemeClr val="accent1"/>
+                </a:solidFill>
+              </a:ln>
+              <a:effectLst/>
+            </c:spPr>
+          </c:dPt>
+          <c:dPt>
+            <c:idx val="4"/>
+            <c:bubble3D val="0"/>
+            <c:spPr>
+              <a:solidFill>
+                <a:schemeClr val="lt1"/>
+              </a:solidFill>
+              <a:ln w="19050">
+                <a:solidFill>
+                  <a:schemeClr val="accent1"/>
+                </a:solidFill>
+              </a:ln>
+              <a:effectLst/>
+            </c:spPr>
+          </c:dPt>
+          <c:dPt>
+            <c:idx val="5"/>
+            <c:bubble3D val="0"/>
+            <c:spPr>
+              <a:solidFill>
+                <a:schemeClr val="lt1"/>
+              </a:solidFill>
+              <a:ln w="19050">
+                <a:solidFill>
+                  <a:schemeClr val="accent1"/>
+                </a:solidFill>
+              </a:ln>
+              <a:effectLst/>
+            </c:spPr>
+          </c:dPt>
+          <c:dPt>
+            <c:idx val="6"/>
+            <c:bubble3D val="0"/>
+            <c:spPr>
+              <a:solidFill>
+                <a:schemeClr val="lt1"/>
+              </a:solidFill>
+              <a:ln w="19050">
+                <a:solidFill>
+                  <a:schemeClr val="accent1"/>
+                </a:solidFill>
+              </a:ln>
+              <a:effectLst/>
+            </c:spPr>
+          </c:dPt>
+          <c:dLbls>
+            <c:spPr>
+              <a:noFill/>
+              <a:ln>
+                <a:noFill/>
+              </a:ln>
+              <a:effectLst/>
+            </c:spPr>
+            <c:txPr>
+              <a:bodyPr rot="0" spcFirstLastPara="1" vertOverflow="ellipsis" vert="horz" wrap="square" lIns="38100" tIns="19050" rIns="38100" bIns="19050" anchor="ctr" anchorCtr="1">
+                <a:spAutoFit/>
+              </a:bodyPr>
+              <a:lstStyle/>
+              <a:p>
+                <a:pPr>
+                  <a:defRPr sz="1197" b="1" i="0" u="none" strike="noStrike" kern="1200" baseline="0">
+                    <a:solidFill>
+                      <a:schemeClr val="accent1"/>
+                    </a:solidFill>
+                    <a:latin typeface="+mn-lt"/>
+                    <a:ea typeface="+mn-ea"/>
+                    <a:cs typeface="+mn-cs"/>
+                  </a:defRPr>
+                </a:pPr>
+                <a:endParaRPr lang="en-US"/>
+              </a:p>
+            </c:txPr>
+            <c:dLblPos val="inEnd"/>
+            <c:showLegendKey val="0"/>
+            <c:showVal val="0"/>
+            <c:showCatName val="1"/>
+            <c:showSerName val="0"/>
+            <c:showPercent val="1"/>
+            <c:showBubbleSize val="0"/>
+            <c:showLeaderLines val="1"/>
+            <c:leaderLines>
+              <c:spPr>
+                <a:ln w="9525">
+                  <a:solidFill>
+                    <a:schemeClr val="accent1">
+                      <a:lumMod val="60000"/>
+                      <a:lumOff val="40000"/>
+                    </a:schemeClr>
+                  </a:solidFill>
+                </a:ln>
+                <a:effectLst/>
+              </c:spPr>
+            </c:leaderLines>
+            <c:extLst>
+              <c:ext xmlns:c15="http://schemas.microsoft.com/office/drawing/2012/chart" uri="{CE6537A1-D6FC-4f65-9D91-7224C49458BB}"/>
+            </c:extLst>
+          </c:dLbls>
+          <c:cat>
+            <c:strRef>
+              <c:f>Sheet1!$A$2:$A$8</c:f>
+              <c:strCache>
+                <c:ptCount val="7"/>
+                <c:pt idx="0">
+                  <c:v>neutral</c:v>
+                </c:pt>
+                <c:pt idx="1">
+                  <c:v>sadness</c:v>
+                </c:pt>
+                <c:pt idx="2">
+                  <c:v>fear</c:v>
+                </c:pt>
+                <c:pt idx="3">
+                  <c:v>happiness</c:v>
+                </c:pt>
+                <c:pt idx="4">
+                  <c:v>disgust</c:v>
+                </c:pt>
+                <c:pt idx="5">
+                  <c:v>surprise</c:v>
+                </c:pt>
+                <c:pt idx="6">
+                  <c:v>anger</c:v>
+                </c:pt>
+              </c:strCache>
+            </c:strRef>
+          </c:cat>
+          <c:val>
+            <c:numRef>
+              <c:f>Sheet1!$B$2:$B$8</c:f>
+              <c:numCache>
+                <c:formatCode>General</c:formatCode>
+                <c:ptCount val="7"/>
+                <c:pt idx="0">
+                  <c:v>38</c:v>
+                </c:pt>
+                <c:pt idx="1">
+                  <c:v>12</c:v>
+                </c:pt>
+                <c:pt idx="2">
+                  <c:v>5.7</c:v>
+                </c:pt>
+                <c:pt idx="3">
+                  <c:v>27</c:v>
+                </c:pt>
+                <c:pt idx="4">
+                  <c:v>5</c:v>
+                </c:pt>
+                <c:pt idx="5">
+                  <c:v>6</c:v>
+                </c:pt>
+              </c:numCache>
+            </c:numRef>
+          </c:val>
+          <c:extLst>
+            <c:ext xmlns:c16="http://schemas.microsoft.com/office/drawing/2014/chart" uri="{C3380CC4-5D6E-409C-BE32-E72D297353CC}">
+              <c16:uniqueId val="{00000000-7DEE-4223-AB78-CF7FD7AFD54D}"/>
+            </c:ext>
+          </c:extLst>
+        </c:ser>
+        <c:dLbls>
+          <c:dLblPos val="inEnd"/>
+          <c:showLegendKey val="0"/>
+          <c:showVal val="0"/>
+          <c:showCatName val="1"/>
+          <c:showSerName val="0"/>
+          <c:showPercent val="1"/>
+          <c:showBubbleSize val="0"/>
+          <c:showLeaderLines val="1"/>
+        </c:dLbls>
+        <c:firstSliceAng val="0"/>
+      </c:pieChart>
+      <c:spPr>
+        <a:noFill/>
+        <a:ln>
+          <a:noFill/>
+        </a:ln>
+        <a:effectLst/>
+      </c:spPr>
+    </c:plotArea>
+    <c:plotVisOnly val="1"/>
+    <c:dispBlanksAs val="gap"/>
+    <c:showDLblsOverMax val="0"/>
+    <c:extLst>
+      <c:ext xmlns:c16r3="http://schemas.microsoft.com/office/drawing/2017/03/chart" uri="{56B9EC1D-385E-4148-901F-78D8002777C0}">
+        <c16r3:dataDisplayOptions16>
+          <c16r3:dispNaAsBlank val="1"/>
+        </c16r3:dataDisplayOptions16>
+      </c:ext>
+    </c:extLst>
+  </c:chart>
+  <c:spPr>
+    <a:solidFill>
+      <a:schemeClr val="accent1"/>
+    </a:solidFill>
+    <a:ln w="9525" cap="flat" cmpd="sng" algn="ctr">
+      <a:solidFill>
+        <a:schemeClr val="accent1"/>
+      </a:solidFill>
+      <a:round/>
+    </a:ln>
+    <a:effectLst/>
+  </c:spPr>
+  <c:txPr>
+    <a:bodyPr/>
+    <a:lstStyle/>
+    <a:p>
+      <a:pPr>
+        <a:defRPr/>
+      </a:pPr>
+      <a:endParaRPr lang="en-US"/>
+    </a:p>
+  </c:txPr>
+  <c:externalData r:id="rId3">
+    <c:autoUpdate val="0"/>
+  </c:externalData>
+</c:chartSpace>
+</file>
+
+<file path=ppt/charts/chart2.xml><?xml version="1.0" encoding="utf-8"?>
+<c:chartSpace xmlns:c="http://schemas.openxmlformats.org/drawingml/2006/chart" xmlns:a="http://schemas.openxmlformats.org/drawingml/2006/main" xmlns:r="http://schemas.openxmlformats.org/officeDocument/2006/relationships" xmlns:c16r2="http://schemas.microsoft.com/office/drawing/2015/06/chart">
+  <c:date1904 val="0"/>
+  <c:lang val="en-GB"/>
+  <c:roundedCorners val="0"/>
+  <mc:AlternateContent xmlns:mc="http://schemas.openxmlformats.org/markup-compatibility/2006">
+    <mc:Choice xmlns:c14="http://schemas.microsoft.com/office/drawing/2007/8/2/chart" Requires="c14">
+      <c14:style val="102"/>
+    </mc:Choice>
+    <mc:Fallback>
+      <c:style val="2"/>
+    </mc:Fallback>
+  </mc:AlternateContent>
+  <c:chart>
+    <c:title>
+      <c:tx>
+        <c:rich>
+          <a:bodyPr rot="0" spcFirstLastPara="1" vertOverflow="ellipsis" vert="horz" wrap="square" anchor="ctr" anchorCtr="1"/>
+          <a:lstStyle/>
+          <a:p>
+            <a:pPr>
+              <a:defRPr sz="1862" b="0" i="0" u="none" strike="noStrike" kern="1200" spc="0" baseline="0">
+                <a:solidFill>
+                  <a:schemeClr val="tx1">
+                    <a:lumMod val="65000"/>
+                    <a:lumOff val="35000"/>
+                  </a:schemeClr>
+                </a:solidFill>
+                <a:latin typeface="+mn-lt"/>
+                <a:ea typeface="+mn-ea"/>
+                <a:cs typeface="+mn-cs"/>
+              </a:defRPr>
+            </a:pPr>
+            <a:r>
+              <a:rPr lang="en-US" dirty="0"/>
+              <a:t>WER</a:t>
+            </a:r>
+            <a:r>
+              <a:rPr lang="en-US" baseline="0" dirty="0"/>
+              <a:t> score</a:t>
+            </a:r>
+            <a:endParaRPr lang="en-US" dirty="0"/>
+          </a:p>
+        </c:rich>
+      </c:tx>
       <c:overlay val="0"/>
       <c:spPr>
         <a:noFill/>
@@ -531,7 +932,571 @@
 </cs:colorStyle>
 </file>
 
+<file path=ppt/charts/colors2.xml><?xml version="1.0" encoding="utf-8"?>
+<cs:colorStyle xmlns:cs="http://schemas.microsoft.com/office/drawing/2012/chartStyle" xmlns:a="http://schemas.openxmlformats.org/drawingml/2006/main" meth="cycle" id="10">
+  <a:schemeClr val="accent1"/>
+  <a:schemeClr val="accent2"/>
+  <a:schemeClr val="accent3"/>
+  <a:schemeClr val="accent4"/>
+  <a:schemeClr val="accent5"/>
+  <a:schemeClr val="accent6"/>
+  <cs:variation/>
+  <cs:variation>
+    <a:lumMod val="60000"/>
+  </cs:variation>
+  <cs:variation>
+    <a:lumMod val="80000"/>
+    <a:lumOff val="20000"/>
+  </cs:variation>
+  <cs:variation>
+    <a:lumMod val="80000"/>
+  </cs:variation>
+  <cs:variation>
+    <a:lumMod val="60000"/>
+    <a:lumOff val="40000"/>
+  </cs:variation>
+  <cs:variation>
+    <a:lumMod val="50000"/>
+  </cs:variation>
+  <cs:variation>
+    <a:lumMod val="70000"/>
+    <a:lumOff val="30000"/>
+  </cs:variation>
+  <cs:variation>
+    <a:lumMod val="70000"/>
+  </cs:variation>
+  <cs:variation>
+    <a:lumMod val="50000"/>
+    <a:lumOff val="50000"/>
+  </cs:variation>
+</cs:colorStyle>
+</file>
+
 <file path=ppt/charts/style1.xml><?xml version="1.0" encoding="utf-8"?>
+<cs:chartStyle xmlns:cs="http://schemas.microsoft.com/office/drawing/2012/chartStyle" xmlns:a="http://schemas.openxmlformats.org/drawingml/2006/main" id="260">
+  <cs:axisTitle>
+    <cs:lnRef idx="0"/>
+    <cs:fillRef idx="0"/>
+    <cs:effectRef idx="0"/>
+    <cs:fontRef idx="minor">
+      <a:schemeClr val="lt1"/>
+    </cs:fontRef>
+    <cs:defRPr sz="1197" b="1" kern="1200"/>
+  </cs:axisTitle>
+  <cs:categoryAxis>
+    <cs:lnRef idx="0">
+      <cs:styleClr val="0"/>
+    </cs:lnRef>
+    <cs:fillRef idx="0"/>
+    <cs:effectRef idx="0"/>
+    <cs:fontRef idx="minor">
+      <a:schemeClr val="lt1"/>
+    </cs:fontRef>
+    <cs:spPr>
+      <a:ln w="3175" cap="flat" cmpd="sng" algn="ctr">
+        <a:solidFill>
+          <a:schemeClr val="phClr">
+            <a:lumMod val="60000"/>
+            <a:lumOff val="40000"/>
+          </a:schemeClr>
+        </a:solidFill>
+        <a:round/>
+      </a:ln>
+    </cs:spPr>
+    <cs:defRPr sz="1064" kern="1200" cap="all" spc="150" normalizeH="0" baseline="0"/>
+  </cs:categoryAxis>
+  <cs:chartArea>
+    <cs:lnRef idx="0">
+      <cs:styleClr val="0"/>
+    </cs:lnRef>
+    <cs:fillRef idx="0">
+      <cs:styleClr val="0"/>
+    </cs:fillRef>
+    <cs:effectRef idx="0"/>
+    <cs:fontRef idx="minor">
+      <a:schemeClr val="dk1"/>
+    </cs:fontRef>
+    <cs:spPr>
+      <a:solidFill>
+        <a:schemeClr val="phClr"/>
+      </a:solidFill>
+      <a:ln w="9525" cap="flat" cmpd="sng" algn="ctr">
+        <a:solidFill>
+          <a:schemeClr val="phClr"/>
+        </a:solidFill>
+        <a:round/>
+      </a:ln>
+    </cs:spPr>
+    <cs:defRPr sz="1330" kern="1200"/>
+  </cs:chartArea>
+  <cs:dataLabel>
+    <cs:lnRef idx="0">
+      <cs:styleClr val="0"/>
+    </cs:lnRef>
+    <cs:fillRef idx="0"/>
+    <cs:effectRef idx="0"/>
+    <cs:fontRef idx="minor">
+      <cs:styleClr val="0"/>
+    </cs:fontRef>
+    <cs:defRPr sz="1197" b="1" kern="1200"/>
+  </cs:dataLabel>
+  <cs:dataLabelCallout>
+    <cs:lnRef idx="0">
+      <cs:styleClr val="0"/>
+    </cs:lnRef>
+    <cs:fillRef idx="0"/>
+    <cs:effectRef idx="0"/>
+    <cs:fontRef idx="minor">
+      <cs:styleClr val="0"/>
+    </cs:fontRef>
+    <cs:spPr>
+      <a:solidFill>
+        <a:schemeClr val="lt1"/>
+      </a:solidFill>
+      <a:ln>
+        <a:solidFill>
+          <a:schemeClr val="phClr"/>
+        </a:solidFill>
+      </a:ln>
+    </cs:spPr>
+    <cs:defRPr sz="1197" b="1" kern="1200"/>
+    <cs:bodyPr rot="0" spcFirstLastPara="1" vertOverflow="clip" horzOverflow="clip" vert="horz" wrap="square" lIns="36576" tIns="18288" rIns="36576" bIns="18288" anchor="ctr" anchorCtr="1">
+      <a:spAutoFit/>
+    </cs:bodyPr>
+  </cs:dataLabelCallout>
+  <cs:dataPoint>
+    <cs:lnRef idx="0">
+      <cs:styleClr val="0"/>
+    </cs:lnRef>
+    <cs:fillRef idx="0"/>
+    <cs:effectRef idx="0"/>
+    <cs:fontRef idx="minor">
+      <a:schemeClr val="dk1"/>
+    </cs:fontRef>
+    <cs:spPr>
+      <a:solidFill>
+        <a:schemeClr val="lt1"/>
+      </a:solidFill>
+      <a:ln w="19050">
+        <a:solidFill>
+          <a:schemeClr val="phClr"/>
+        </a:solidFill>
+      </a:ln>
+    </cs:spPr>
+  </cs:dataPoint>
+  <cs:dataPoint3D>
+    <cs:lnRef idx="0"/>
+    <cs:fillRef idx="0">
+      <cs:styleClr val="auto"/>
+    </cs:fillRef>
+    <cs:effectRef idx="0"/>
+    <cs:fontRef idx="minor">
+      <a:schemeClr val="dk1"/>
+    </cs:fontRef>
+    <cs:spPr>
+      <a:solidFill>
+        <a:schemeClr val="phClr"/>
+      </a:solidFill>
+    </cs:spPr>
+  </cs:dataPoint3D>
+  <cs:dataPointLine>
+    <cs:lnRef idx="0">
+      <cs:styleClr val="auto"/>
+    </cs:lnRef>
+    <cs:fillRef idx="0"/>
+    <cs:effectRef idx="0">
+      <cs:styleClr val="auto"/>
+    </cs:effectRef>
+    <cs:fontRef idx="minor">
+      <a:schemeClr val="dk1"/>
+    </cs:fontRef>
+    <cs:spPr>
+      <a:ln w="34925" cap="rnd">
+        <a:solidFill>
+          <a:schemeClr val="lt1"/>
+        </a:solidFill>
+        <a:round/>
+      </a:ln>
+      <a:effectLst>
+        <a:outerShdw dist="25400" dir="2700000" algn="tl" rotWithShape="0">
+          <a:schemeClr val="phClr"/>
+        </a:outerShdw>
+      </a:effectLst>
+    </cs:spPr>
+  </cs:dataPointLine>
+  <cs:dataPointMarker>
+    <cs:lnRef idx="0"/>
+    <cs:fillRef idx="0">
+      <cs:styleClr val="auto"/>
+    </cs:fillRef>
+    <cs:effectRef idx="0"/>
+    <cs:fontRef idx="minor">
+      <a:schemeClr val="dk1"/>
+    </cs:fontRef>
+    <cs:spPr>
+      <a:solidFill>
+        <a:schemeClr val="phClr"/>
+      </a:solidFill>
+      <a:ln w="22225">
+        <a:solidFill>
+          <a:schemeClr val="lt1"/>
+        </a:solidFill>
+        <a:round/>
+      </a:ln>
+    </cs:spPr>
+  </cs:dataPointMarker>
+  <cs:dataPointMarkerLayout symbol="circle" size="5"/>
+  <cs:dataPointWireframe>
+    <cs:lnRef idx="0">
+      <cs:styleClr val="auto"/>
+    </cs:lnRef>
+    <cs:fillRef idx="0"/>
+    <cs:effectRef idx="0"/>
+    <cs:fontRef idx="minor">
+      <a:schemeClr val="dk1"/>
+    </cs:fontRef>
+    <cs:spPr>
+      <a:ln w="9525" cap="rnd">
+        <a:solidFill>
+          <a:schemeClr val="phClr"/>
+        </a:solidFill>
+        <a:round/>
+      </a:ln>
+    </cs:spPr>
+  </cs:dataPointWireframe>
+  <cs:dataTable>
+    <cs:lnRef idx="0">
+      <cs:styleClr val="0"/>
+    </cs:lnRef>
+    <cs:fillRef idx="0"/>
+    <cs:effectRef idx="0"/>
+    <cs:fontRef idx="minor">
+      <a:schemeClr val="lt1"/>
+    </cs:fontRef>
+    <cs:spPr>
+      <a:ln w="9525">
+        <a:solidFill>
+          <a:schemeClr val="phClr">
+            <a:lumMod val="60000"/>
+            <a:lumOff val="40000"/>
+          </a:schemeClr>
+        </a:solidFill>
+      </a:ln>
+    </cs:spPr>
+    <cs:defRPr sz="1197" kern="1200"/>
+  </cs:dataTable>
+  <cs:downBar>
+    <cs:lnRef idx="0">
+      <cs:styleClr val="0"/>
+    </cs:lnRef>
+    <cs:fillRef idx="0"/>
+    <cs:effectRef idx="0"/>
+    <cs:fontRef idx="minor">
+      <a:schemeClr val="dk1"/>
+    </cs:fontRef>
+    <cs:spPr>
+      <a:solidFill>
+        <a:schemeClr val="dk1">
+          <a:lumMod val="35000"/>
+          <a:lumOff val="65000"/>
+        </a:schemeClr>
+      </a:solidFill>
+      <a:ln w="9525">
+        <a:solidFill>
+          <a:schemeClr val="phClr">
+            <a:lumMod val="60000"/>
+            <a:lumOff val="40000"/>
+          </a:schemeClr>
+        </a:solidFill>
+      </a:ln>
+    </cs:spPr>
+  </cs:downBar>
+  <cs:dropLine>
+    <cs:lnRef idx="0">
+      <cs:styleClr val="0"/>
+    </cs:lnRef>
+    <cs:fillRef idx="0"/>
+    <cs:effectRef idx="0"/>
+    <cs:fontRef idx="minor">
+      <a:schemeClr val="dk1"/>
+    </cs:fontRef>
+    <cs:spPr>
+      <a:ln w="9525">
+        <a:solidFill>
+          <a:schemeClr val="phClr">
+            <a:lumMod val="60000"/>
+            <a:lumOff val="40000"/>
+          </a:schemeClr>
+        </a:solidFill>
+        <a:prstDash val="dash"/>
+      </a:ln>
+    </cs:spPr>
+  </cs:dropLine>
+  <cs:errorBar>
+    <cs:lnRef idx="0">
+      <cs:styleClr val="0"/>
+    </cs:lnRef>
+    <cs:fillRef idx="0"/>
+    <cs:effectRef idx="0"/>
+    <cs:fontRef idx="minor">
+      <a:schemeClr val="dk1"/>
+    </cs:fontRef>
+    <cs:spPr>
+      <a:ln w="9525">
+        <a:solidFill>
+          <a:schemeClr val="phClr">
+            <a:lumMod val="60000"/>
+            <a:lumOff val="40000"/>
+          </a:schemeClr>
+        </a:solidFill>
+        <a:round/>
+      </a:ln>
+      <a:effectLst>
+        <a:glow rad="25400">
+          <a:schemeClr val="lt1"/>
+        </a:glow>
+      </a:effectLst>
+    </cs:spPr>
+  </cs:errorBar>
+  <cs:floor>
+    <cs:lnRef idx="0"/>
+    <cs:fillRef idx="0"/>
+    <cs:effectRef idx="0"/>
+    <cs:fontRef idx="minor">
+      <a:schemeClr val="dk1"/>
+    </cs:fontRef>
+  </cs:floor>
+  <cs:gridlineMajor>
+    <cs:lnRef idx="0">
+      <cs:styleClr val="0"/>
+    </cs:lnRef>
+    <cs:fillRef idx="0"/>
+    <cs:effectRef idx="0"/>
+    <cs:fontRef idx="minor">
+      <a:schemeClr val="dk1"/>
+    </cs:fontRef>
+    <cs:spPr>
+      <a:ln w="9525" cap="flat" cmpd="sng" algn="ctr">
+        <a:solidFill>
+          <a:schemeClr val="lt1">
+            <a:alpha val="25000"/>
+          </a:schemeClr>
+        </a:solidFill>
+        <a:round/>
+      </a:ln>
+    </cs:spPr>
+  </cs:gridlineMajor>
+  <cs:gridlineMinor>
+    <cs:lnRef idx="0">
+      <cs:styleClr val="0"/>
+    </cs:lnRef>
+    <cs:fillRef idx="0"/>
+    <cs:effectRef idx="0"/>
+    <cs:fontRef idx="minor">
+      <a:schemeClr val="dk1"/>
+    </cs:fontRef>
+    <cs:spPr>
+      <a:ln>
+        <a:solidFill>
+          <a:schemeClr val="lt1">
+            <a:alpha val="10000"/>
+          </a:schemeClr>
+        </a:solidFill>
+      </a:ln>
+    </cs:spPr>
+  </cs:gridlineMinor>
+  <cs:hiLoLine>
+    <cs:lnRef idx="0">
+      <cs:styleClr val="0"/>
+    </cs:lnRef>
+    <cs:fillRef idx="0"/>
+    <cs:effectRef idx="0"/>
+    <cs:fontRef idx="minor">
+      <a:schemeClr val="dk1"/>
+    </cs:fontRef>
+    <cs:spPr>
+      <a:ln w="9525">
+        <a:solidFill>
+          <a:schemeClr val="phClr">
+            <a:lumMod val="60000"/>
+            <a:lumOff val="40000"/>
+          </a:schemeClr>
+        </a:solidFill>
+        <a:prstDash val="dash"/>
+      </a:ln>
+    </cs:spPr>
+  </cs:hiLoLine>
+  <cs:leaderLine>
+    <cs:lnRef idx="0">
+      <cs:styleClr val="0"/>
+    </cs:lnRef>
+    <cs:fillRef idx="0"/>
+    <cs:effectRef idx="0"/>
+    <cs:fontRef idx="minor">
+      <a:schemeClr val="dk1"/>
+    </cs:fontRef>
+    <cs:spPr>
+      <a:ln w="9525">
+        <a:solidFill>
+          <a:schemeClr val="phClr">
+            <a:lumMod val="60000"/>
+            <a:lumOff val="40000"/>
+          </a:schemeClr>
+        </a:solidFill>
+      </a:ln>
+    </cs:spPr>
+  </cs:leaderLine>
+  <cs:legend>
+    <cs:lnRef idx="0"/>
+    <cs:fillRef idx="0"/>
+    <cs:effectRef idx="0"/>
+    <cs:fontRef idx="minor">
+      <a:schemeClr val="lt1"/>
+    </cs:fontRef>
+    <cs:defRPr sz="1197" kern="1200"/>
+  </cs:legend>
+  <cs:plotArea>
+    <cs:lnRef idx="0"/>
+    <cs:fillRef idx="0"/>
+    <cs:effectRef idx="0"/>
+    <cs:fontRef idx="minor">
+      <a:schemeClr val="dk1"/>
+    </cs:fontRef>
+  </cs:plotArea>
+  <cs:plotArea3D>
+    <cs:lnRef idx="0"/>
+    <cs:fillRef idx="0"/>
+    <cs:effectRef idx="0"/>
+    <cs:fontRef idx="minor">
+      <a:schemeClr val="dk1"/>
+    </cs:fontRef>
+  </cs:plotArea3D>
+  <cs:seriesAxis>
+    <cs:lnRef idx="0">
+      <cs:styleClr val="0"/>
+    </cs:lnRef>
+    <cs:fillRef idx="0"/>
+    <cs:effectRef idx="0"/>
+    <cs:fontRef idx="minor">
+      <a:schemeClr val="lt1"/>
+    </cs:fontRef>
+    <cs:spPr>
+      <a:ln w="3175" cap="flat" cmpd="sng" algn="ctr">
+        <a:solidFill>
+          <a:schemeClr val="phClr">
+            <a:lumMod val="60000"/>
+            <a:lumOff val="40000"/>
+          </a:schemeClr>
+        </a:solidFill>
+        <a:round/>
+      </a:ln>
+    </cs:spPr>
+    <cs:defRPr sz="1197" kern="1200"/>
+  </cs:seriesAxis>
+  <cs:seriesLine>
+    <cs:lnRef idx="0">
+      <cs:styleClr val="0"/>
+    </cs:lnRef>
+    <cs:fillRef idx="0"/>
+    <cs:effectRef idx="0"/>
+    <cs:fontRef idx="minor">
+      <a:schemeClr val="dk1"/>
+    </cs:fontRef>
+    <cs:spPr>
+      <a:ln w="9525">
+        <a:solidFill>
+          <a:schemeClr val="phClr">
+            <a:lumMod val="60000"/>
+            <a:lumOff val="40000"/>
+            <a:tint val="50000"/>
+          </a:schemeClr>
+        </a:solidFill>
+        <a:prstDash val="dash"/>
+      </a:ln>
+    </cs:spPr>
+  </cs:seriesLine>
+  <cs:title>
+    <cs:lnRef idx="0"/>
+    <cs:fillRef idx="0"/>
+    <cs:effectRef idx="0"/>
+    <cs:fontRef idx="minor">
+      <a:schemeClr val="lt1"/>
+    </cs:fontRef>
+    <cs:defRPr sz="1995" b="1" kern="1200" cap="all" spc="100" normalizeH="0" baseline="0"/>
+  </cs:title>
+  <cs:trendline>
+    <cs:lnRef idx="0"/>
+    <cs:fillRef idx="0"/>
+    <cs:effectRef idx="0"/>
+    <cs:fontRef idx="minor">
+      <a:schemeClr val="dk1"/>
+    </cs:fontRef>
+    <cs:spPr>
+      <a:ln w="28575" cap="rnd">
+        <a:solidFill>
+          <a:schemeClr val="lt1">
+            <a:alpha val="50000"/>
+          </a:schemeClr>
+        </a:solidFill>
+        <a:round/>
+      </a:ln>
+    </cs:spPr>
+  </cs:trendline>
+  <cs:trendlineLabel>
+    <cs:lnRef idx="0"/>
+    <cs:fillRef idx="0"/>
+    <cs:effectRef idx="0"/>
+    <cs:fontRef idx="minor">
+      <a:schemeClr val="lt1"/>
+    </cs:fontRef>
+    <cs:defRPr sz="1197" kern="1200"/>
+  </cs:trendlineLabel>
+  <cs:upBar>
+    <cs:lnRef idx="0">
+      <cs:styleClr val="0"/>
+    </cs:lnRef>
+    <cs:fillRef idx="0"/>
+    <cs:effectRef idx="0"/>
+    <cs:fontRef idx="minor">
+      <a:schemeClr val="dk1"/>
+    </cs:fontRef>
+    <cs:spPr>
+      <a:solidFill>
+        <a:schemeClr val="lt1">
+          <a:lumMod val="95000"/>
+        </a:schemeClr>
+      </a:solidFill>
+      <a:ln w="9525">
+        <a:solidFill>
+          <a:schemeClr val="phClr">
+            <a:lumMod val="60000"/>
+            <a:lumOff val="40000"/>
+          </a:schemeClr>
+        </a:solidFill>
+      </a:ln>
+    </cs:spPr>
+  </cs:upBar>
+  <cs:valueAxis>
+    <cs:lnRef idx="0"/>
+    <cs:fillRef idx="0"/>
+    <cs:effectRef idx="0"/>
+    <cs:fontRef idx="minor">
+      <a:schemeClr val="lt1"/>
+    </cs:fontRef>
+    <cs:defRPr sz="1197" kern="1200"/>
+  </cs:valueAxis>
+  <cs:wall>
+    <cs:lnRef idx="0"/>
+    <cs:fillRef idx="0"/>
+    <cs:effectRef idx="0"/>
+    <cs:fontRef idx="minor">
+      <a:schemeClr val="dk1"/>
+    </cs:fontRef>
+  </cs:wall>
+</cs:chartStyle>
+</file>
+
+<file path=ppt/charts/style2.xml><?xml version="1.0" encoding="utf-8"?>
 <cs:chartStyle xmlns:cs="http://schemas.microsoft.com/office/drawing/2012/chartStyle" xmlns:a="http://schemas.openxmlformats.org/drawingml/2006/main" id="201">
   <cs:axisTitle>
     <cs:lnRef idx="0"/>
@@ -6576,10 +7541,24 @@
     <dgm:pt modelId="{93AE4536-94FF-4693-A2AC-282D82FC5A8F}" type="parTrans" cxnId="{598C5206-B472-4CA0-A36B-1B6FC5D3D89E}">
       <dgm:prSet/>
       <dgm:spPr/>
+      <dgm:t>
+        <a:bodyPr/>
+        <a:lstStyle/>
+        <a:p>
+          <a:endParaRPr lang="en-US"/>
+        </a:p>
+      </dgm:t>
     </dgm:pt>
     <dgm:pt modelId="{124097A3-EFEB-49F4-AFBF-01BC820378FC}" type="sibTrans" cxnId="{598C5206-B472-4CA0-A36B-1B6FC5D3D89E}">
       <dgm:prSet/>
       <dgm:spPr/>
+      <dgm:t>
+        <a:bodyPr/>
+        <a:lstStyle/>
+        <a:p>
+          <a:endParaRPr lang="en-US"/>
+        </a:p>
+      </dgm:t>
     </dgm:pt>
     <dgm:pt modelId="{B3764324-48B6-4954-B59D-ED87906E6E40}">
       <dgm:prSet phldr="0"/>
@@ -6605,10 +7584,24 @@
     <dgm:pt modelId="{00FCE382-F4EB-4E67-852D-6E4DFDFC87DB}" type="parTrans" cxnId="{99292A76-C58B-419F-A724-6ED3774F36ED}">
       <dgm:prSet/>
       <dgm:spPr/>
+      <dgm:t>
+        <a:bodyPr/>
+        <a:lstStyle/>
+        <a:p>
+          <a:endParaRPr lang="en-US"/>
+        </a:p>
+      </dgm:t>
     </dgm:pt>
     <dgm:pt modelId="{FCC1BBA6-C412-4F30-9F9C-22DFAF06AF5D}" type="sibTrans" cxnId="{99292A76-C58B-419F-A724-6ED3774F36ED}">
       <dgm:prSet/>
       <dgm:spPr/>
+      <dgm:t>
+        <a:bodyPr/>
+        <a:lstStyle/>
+        <a:p>
+          <a:endParaRPr lang="en-US"/>
+        </a:p>
+      </dgm:t>
     </dgm:pt>
     <dgm:pt modelId="{25294331-00D8-466A-A5FB-AE508644205F}" type="pres">
       <dgm:prSet presAssocID="{1ECF7AC2-B693-4EAF-9B8A-EE39054A7238}" presName="root" presStyleCnt="0">
@@ -7161,10 +8154,9 @@
             </a:lnSpc>
           </a:pPr>
           <a:r>
-            <a:rPr lang="nl-NL"/>
-            <a:t>Problems</a:t>
+            <a:rPr lang="en-US" dirty="0"/>
+            <a:t>Results</a:t>
           </a:r>
-          <a:endParaRPr lang="en-US"/>
         </a:p>
       </dgm:t>
     </dgm:pt>
@@ -7203,10 +8195,9 @@
             </a:lnSpc>
           </a:pPr>
           <a:r>
-            <a:rPr lang="nl-NL"/>
-            <a:t>Tradeoff</a:t>
+            <a:rPr lang="en-US" dirty="0"/>
+            <a:t>Problems</a:t>
           </a:r>
-          <a:endParaRPr lang="en-US"/>
         </a:p>
       </dgm:t>
     </dgm:pt>
@@ -7245,10 +8236,10 @@
             </a:lnSpc>
           </a:pPr>
           <a:r>
-            <a:rPr lang="nl-NL"/>
-            <a:t>Results</a:t>
+            <a:rPr lang="en-US" dirty="0" err="1"/>
+            <a:t>TradeOff</a:t>
           </a:r>
-          <a:endParaRPr lang="en-US"/>
+          <a:endParaRPr lang="en-US" dirty="0"/>
         </a:p>
       </dgm:t>
     </dgm:pt>
@@ -7488,7 +8479,7 @@
       <dgm:spPr/>
     </dgm:pt>
     <dgm:pt modelId="{15C2A586-E319-420B-8AF6-11BC30B3C666}" type="pres">
-      <dgm:prSet presAssocID="{C32E4095-20A9-4087-8FD6-50D11C73548E}" presName="bgRect" presStyleLbl="bgShp" presStyleIdx="4" presStyleCnt="5"/>
+      <dgm:prSet presAssocID="{C32E4095-20A9-4087-8FD6-50D11C73548E}" presName="bgRect" presStyleLbl="bgShp" presStyleIdx="4" presStyleCnt="5" custLinFactNeighborX="175" custLinFactNeighborY="-6635"/>
       <dgm:spPr/>
     </dgm:pt>
     <dgm:pt modelId="{A0B5B446-BC9D-46B1-826B-8F8DF9402DF8}" type="pres">
@@ -9106,7 +10097,7 @@
       <dsp:spPr>
         <a:xfrm>
           <a:off x="0" y="531"/>
-          <a:ext cx="8595360" cy="446182"/>
+          <a:ext cx="4363675" cy="446182"/>
         </a:xfrm>
         <a:prstGeom prst="roundRect">
           <a:avLst>
@@ -9204,7 +10195,7 @@
       <dsp:spPr>
         <a:xfrm>
           <a:off x="515340" y="531"/>
-          <a:ext cx="8080019" cy="446182"/>
+          <a:ext cx="3848334" cy="446182"/>
         </a:xfrm>
         <a:prstGeom prst="rect">
           <a:avLst/>
@@ -9254,7 +10245,7 @@
       </dsp:txBody>
       <dsp:txXfrm>
         <a:off x="515340" y="531"/>
-        <a:ext cx="8080019" cy="446182"/>
+        <a:ext cx="3848334" cy="446182"/>
       </dsp:txXfrm>
     </dsp:sp>
     <dsp:sp modelId="{1F3C5140-6B74-493D-AAF2-09457E41EA02}">
@@ -9265,7 +10256,7 @@
       <dsp:spPr>
         <a:xfrm>
           <a:off x="0" y="558258"/>
-          <a:ext cx="8595360" cy="446182"/>
+          <a:ext cx="4363675" cy="446182"/>
         </a:xfrm>
         <a:prstGeom prst="roundRect">
           <a:avLst>
@@ -9363,7 +10354,7 @@
       <dsp:spPr>
         <a:xfrm>
           <a:off x="515340" y="558258"/>
-          <a:ext cx="8080019" cy="446182"/>
+          <a:ext cx="3848334" cy="446182"/>
         </a:xfrm>
         <a:prstGeom prst="rect">
           <a:avLst/>
@@ -9413,7 +10404,7 @@
       </dsp:txBody>
       <dsp:txXfrm>
         <a:off x="515340" y="558258"/>
-        <a:ext cx="8080019" cy="446182"/>
+        <a:ext cx="3848334" cy="446182"/>
       </dsp:txXfrm>
     </dsp:sp>
     <dsp:sp modelId="{CF38D8CC-38A0-44A2-B1B0-FFB297AF861F}">
@@ -9424,7 +10415,7 @@
       <dsp:spPr>
         <a:xfrm>
           <a:off x="0" y="1115986"/>
-          <a:ext cx="8595360" cy="446182"/>
+          <a:ext cx="4363675" cy="446182"/>
         </a:xfrm>
         <a:prstGeom prst="roundRect">
           <a:avLst>
@@ -9515,7 +10506,7 @@
       <dsp:spPr>
         <a:xfrm>
           <a:off x="515340" y="1115986"/>
-          <a:ext cx="8080019" cy="446182"/>
+          <a:ext cx="3848334" cy="446182"/>
         </a:xfrm>
         <a:prstGeom prst="rect">
           <a:avLst/>
@@ -9566,7 +10557,7 @@
       </dsp:txBody>
       <dsp:txXfrm>
         <a:off x="515340" y="1115986"/>
-        <a:ext cx="8080019" cy="446182"/>
+        <a:ext cx="3848334" cy="446182"/>
       </dsp:txXfrm>
     </dsp:sp>
     <dsp:sp modelId="{9B8D6229-FE49-4DB4-9FB3-F75E1DADCB77}">
@@ -9577,7 +10568,7 @@
       <dsp:spPr>
         <a:xfrm>
           <a:off x="0" y="1673713"/>
-          <a:ext cx="8595360" cy="446182"/>
+          <a:ext cx="4363675" cy="446182"/>
         </a:xfrm>
         <a:prstGeom prst="roundRect">
           <a:avLst>
@@ -9675,7 +10666,7 @@
       <dsp:spPr>
         <a:xfrm>
           <a:off x="515340" y="1673713"/>
-          <a:ext cx="8080019" cy="446182"/>
+          <a:ext cx="3848334" cy="446182"/>
         </a:xfrm>
         <a:prstGeom prst="rect">
           <a:avLst/>
@@ -9725,7 +10716,7 @@
       </dsp:txBody>
       <dsp:txXfrm>
         <a:off x="515340" y="1673713"/>
-        <a:ext cx="8080019" cy="446182"/>
+        <a:ext cx="3848334" cy="446182"/>
       </dsp:txXfrm>
     </dsp:sp>
     <dsp:sp modelId="{30C8ABFD-39FA-46C0-AC2A-1D34F70EEA98}">
@@ -9736,7 +10727,7 @@
       <dsp:spPr>
         <a:xfrm>
           <a:off x="0" y="2231441"/>
-          <a:ext cx="8595360" cy="446182"/>
+          <a:ext cx="4363675" cy="446182"/>
         </a:xfrm>
         <a:prstGeom prst="roundRect">
           <a:avLst>
@@ -9834,7 +10825,7 @@
       <dsp:spPr>
         <a:xfrm>
           <a:off x="515340" y="2231441"/>
-          <a:ext cx="8080019" cy="446182"/>
+          <a:ext cx="3848334" cy="446182"/>
         </a:xfrm>
         <a:prstGeom prst="rect">
           <a:avLst/>
@@ -9884,7 +10875,7 @@
       </dsp:txBody>
       <dsp:txXfrm>
         <a:off x="515340" y="2231441"/>
-        <a:ext cx="8080019" cy="446182"/>
+        <a:ext cx="3848334" cy="446182"/>
       </dsp:txXfrm>
     </dsp:sp>
     <dsp:sp modelId="{977480E0-DCF1-4ABC-A929-95342EC813F0}">
@@ -9895,7 +10886,7 @@
       <dsp:spPr>
         <a:xfrm>
           <a:off x="0" y="2789168"/>
-          <a:ext cx="8595360" cy="446182"/>
+          <a:ext cx="4363675" cy="446182"/>
         </a:xfrm>
         <a:prstGeom prst="roundRect">
           <a:avLst>
@@ -9993,7 +10984,7 @@
       <dsp:spPr>
         <a:xfrm>
           <a:off x="515340" y="2789168"/>
-          <a:ext cx="8080019" cy="446182"/>
+          <a:ext cx="3848334" cy="446182"/>
         </a:xfrm>
         <a:prstGeom prst="rect">
           <a:avLst/>
@@ -10043,7 +11034,7 @@
       </dsp:txBody>
       <dsp:txXfrm>
         <a:off x="515340" y="2789168"/>
-        <a:ext cx="8080019" cy="446182"/>
+        <a:ext cx="3848334" cy="446182"/>
       </dsp:txXfrm>
     </dsp:sp>
     <dsp:sp modelId="{2E7595FA-4BC7-496B-923B-5EAA3CE9655B}">
@@ -10054,7 +11045,7 @@
       <dsp:spPr>
         <a:xfrm>
           <a:off x="0" y="3346896"/>
-          <a:ext cx="8595360" cy="446182"/>
+          <a:ext cx="4363675" cy="446182"/>
         </a:xfrm>
         <a:prstGeom prst="roundRect">
           <a:avLst>
@@ -10152,7 +11143,7 @@
       <dsp:spPr>
         <a:xfrm>
           <a:off x="515340" y="3346896"/>
-          <a:ext cx="8080019" cy="446182"/>
+          <a:ext cx="3848334" cy="446182"/>
         </a:xfrm>
         <a:prstGeom prst="rect">
           <a:avLst/>
@@ -10202,7 +11193,7 @@
       </dsp:txBody>
       <dsp:txXfrm>
         <a:off x="515340" y="3346896"/>
-        <a:ext cx="8080019" cy="446182"/>
+        <a:ext cx="3848334" cy="446182"/>
       </dsp:txXfrm>
     </dsp:sp>
     <dsp:sp modelId="{5790F865-9A4D-4A79-8FB1-2B9C7A02FCF8}">
@@ -10213,7 +11204,7 @@
       <dsp:spPr>
         <a:xfrm>
           <a:off x="0" y="3904623"/>
-          <a:ext cx="8595360" cy="446182"/>
+          <a:ext cx="4363675" cy="446182"/>
         </a:xfrm>
         <a:prstGeom prst="roundRect">
           <a:avLst>
@@ -10304,7 +11295,7 @@
       <dsp:spPr>
         <a:xfrm>
           <a:off x="515340" y="3904623"/>
-          <a:ext cx="8080019" cy="446182"/>
+          <a:ext cx="3848334" cy="446182"/>
         </a:xfrm>
         <a:prstGeom prst="rect">
           <a:avLst/>
@@ -10355,7 +11346,7 @@
       </dsp:txBody>
       <dsp:txXfrm>
         <a:off x="515340" y="3904623"/>
-        <a:ext cx="8080019" cy="446182"/>
+        <a:ext cx="3848334" cy="446182"/>
       </dsp:txXfrm>
     </dsp:sp>
   </dsp:spTree>
@@ -10836,10 +11827,9 @@
             <a:buNone/>
           </a:pPr>
           <a:r>
-            <a:rPr lang="nl-NL" sz="1900" kern="1200"/>
-            <a:t>Problems</a:t>
+            <a:rPr lang="en-US" sz="1900" kern="1200" dirty="0"/>
+            <a:t>Results</a:t>
           </a:r>
-          <a:endParaRPr lang="en-US" sz="1900" kern="1200"/>
         </a:p>
       </dsp:txBody>
       <dsp:txXfrm>
@@ -10995,10 +11985,9 @@
             <a:buNone/>
           </a:pPr>
           <a:r>
-            <a:rPr lang="nl-NL" sz="1900" kern="1200"/>
-            <a:t>Tradeoff</a:t>
+            <a:rPr lang="en-US" sz="1900" kern="1200" dirty="0"/>
+            <a:t>Problems</a:t>
           </a:r>
-          <a:endParaRPr lang="en-US" sz="1900" kern="1200"/>
         </a:p>
       </dsp:txBody>
       <dsp:txXfrm>
@@ -11013,7 +12002,7 @@
       </dsp:nvSpPr>
       <dsp:spPr>
         <a:xfrm>
-          <a:off x="0" y="3707951"/>
+          <a:off x="0" y="3658792"/>
           <a:ext cx="6887746" cy="740894"/>
         </a:xfrm>
         <a:prstGeom prst="roundRect">
@@ -11154,10 +12143,10 @@
             <a:buNone/>
           </a:pPr>
           <a:r>
-            <a:rPr lang="nl-NL" sz="1900" kern="1200"/>
-            <a:t>Results</a:t>
+            <a:rPr lang="en-US" sz="1900" kern="1200" dirty="0" err="1"/>
+            <a:t>TradeOff</a:t>
           </a:r>
-          <a:endParaRPr lang="en-US" sz="1900" kern="1200"/>
+          <a:endParaRPr lang="en-US" sz="1900" kern="1200" dirty="0"/>
         </a:p>
       </dsp:txBody>
       <dsp:txXfrm>
@@ -25377,7 +26366,9 @@
         </p:nvSpPr>
         <p:spPr/>
         <p:txBody>
-          <a:bodyPr/>
+          <a:bodyPr>
+            <a:normAutofit lnSpcReduction="10000"/>
+          </a:bodyPr>
           <a:lstStyle/>
           <a:p>
             <a:fld id="{75B80215-FF61-4755-832C-0ADA91C81061}" type="slidenum">
@@ -25573,7 +26564,9 @@
         </p:nvSpPr>
         <p:spPr/>
         <p:txBody>
-          <a:bodyPr/>
+          <a:bodyPr>
+            <a:normAutofit lnSpcReduction="10000"/>
+          </a:bodyPr>
           <a:lstStyle/>
           <a:p>
             <a:fld id="{75B80215-FF61-4755-832C-0ADA91C81061}" type="slidenum">
@@ -25725,7 +26718,9 @@
         </p:nvSpPr>
         <p:spPr/>
         <p:txBody>
-          <a:bodyPr/>
+          <a:bodyPr>
+            <a:normAutofit lnSpcReduction="10000"/>
+          </a:bodyPr>
           <a:lstStyle/>
           <a:p>
             <a:fld id="{75B80215-FF61-4755-832C-0ADA91C81061}" type="slidenum">
@@ -25812,7 +26807,9 @@
         </p:nvSpPr>
         <p:spPr/>
         <p:txBody>
-          <a:bodyPr/>
+          <a:bodyPr>
+            <a:normAutofit lnSpcReduction="10000"/>
+          </a:bodyPr>
           <a:lstStyle/>
           <a:p>
             <a:fld id="{75B80215-FF61-4755-832C-0ADA91C81061}" type="slidenum">
@@ -26101,7 +27098,9 @@
         </p:nvSpPr>
         <p:spPr/>
         <p:txBody>
-          <a:bodyPr/>
+          <a:bodyPr>
+            <a:normAutofit lnSpcReduction="10000"/>
+          </a:bodyPr>
           <a:lstStyle/>
           <a:p>
             <a:fld id="{75B80215-FF61-4755-832C-0ADA91C81061}" type="slidenum">
@@ -26387,7 +27386,9 @@
         </p:nvSpPr>
         <p:spPr/>
         <p:txBody>
-          <a:bodyPr/>
+          <a:bodyPr>
+            <a:normAutofit lnSpcReduction="10000"/>
+          </a:bodyPr>
           <a:lstStyle/>
           <a:p>
             <a:fld id="{75B80215-FF61-4755-832C-0ADA91C81061}" type="slidenum">
@@ -26534,7 +27535,9 @@
         </p:nvSpPr>
         <p:spPr/>
         <p:txBody>
-          <a:bodyPr/>
+          <a:bodyPr>
+            <a:normAutofit lnSpcReduction="10000"/>
+          </a:bodyPr>
           <a:lstStyle/>
           <a:p>
             <a:fld id="{75B80215-FF61-4755-832C-0ADA91C81061}" type="slidenum">
@@ -26621,7 +27624,9 @@
         </p:nvSpPr>
         <p:spPr/>
         <p:txBody>
-          <a:bodyPr/>
+          <a:bodyPr>
+            <a:normAutofit lnSpcReduction="10000"/>
+          </a:bodyPr>
           <a:lstStyle/>
           <a:p>
             <a:fld id="{75B80215-FF61-4755-832C-0ADA91C81061}" type="slidenum">
@@ -26778,14 +27783,14 @@
             <p:ph idx="1"/>
             <p:extLst>
               <p:ext uri="{D42A27DB-BD31-4B8C-83A1-F6EECF244321}">
-                <p14:modId xmlns:p14="http://schemas.microsoft.com/office/powerpoint/2010/main" val="705126140"/>
+                <p14:modId xmlns:p14="http://schemas.microsoft.com/office/powerpoint/2010/main" val="832684337"/>
               </p:ext>
             </p:extLst>
           </p:nvPr>
         </p:nvGraphicFramePr>
         <p:xfrm>
-          <a:off x="1261872" y="1828800"/>
-          <a:ext cx="8595360" cy="4351337"/>
+          <a:off x="1261873" y="1828800"/>
+          <a:ext cx="4363675" cy="4351337"/>
         </p:xfrm>
         <a:graphic>
           <a:graphicData uri="http://schemas.openxmlformats.org/drawingml/2006/diagram">
@@ -26811,7 +27816,9 @@
         </p:nvSpPr>
         <p:spPr/>
         <p:txBody>
-          <a:bodyPr/>
+          <a:bodyPr>
+            <a:normAutofit lnSpcReduction="10000"/>
+          </a:bodyPr>
           <a:lstStyle/>
           <a:p>
             <a:fld id="{75B80215-FF61-4755-832C-0ADA91C81061}" type="slidenum">
@@ -26822,6 +27829,34 @@
           </a:p>
         </p:txBody>
       </p:sp>
+      <p:graphicFrame>
+        <p:nvGraphicFramePr>
+          <p:cNvPr id="6" name="Chart 5">
+            <a:extLst>
+              <a:ext uri="{FF2B5EF4-FFF2-40B4-BE49-F238E27FC236}">
+                <a16:creationId xmlns:a16="http://schemas.microsoft.com/office/drawing/2014/main" id="{E285E80A-8E01-4856-4F10-25094A3066F9}"/>
+              </a:ext>
+            </a:extLst>
+          </p:cNvPr>
+          <p:cNvGraphicFramePr/>
+          <p:nvPr>
+            <p:extLst>
+              <p:ext uri="{D42A27DB-BD31-4B8C-83A1-F6EECF244321}">
+                <p14:modId xmlns:p14="http://schemas.microsoft.com/office/powerpoint/2010/main" val="777231279"/>
+              </p:ext>
+            </p:extLst>
+          </p:nvPr>
+        </p:nvGraphicFramePr>
+        <p:xfrm>
+          <a:off x="6192078" y="2097157"/>
+          <a:ext cx="4909149" cy="3866321"/>
+        </p:xfrm>
+        <a:graphic>
+          <a:graphicData uri="http://schemas.openxmlformats.org/drawingml/2006/chart">
+            <c:chart xmlns:c="http://schemas.openxmlformats.org/drawingml/2006/chart" xmlns:r="http://schemas.openxmlformats.org/officeDocument/2006/relationships" r:id="rId8"/>
+          </a:graphicData>
+        </a:graphic>
+      </p:graphicFrame>
     </p:spTree>
     <p:extLst>
       <p:ext uri="{BB962C8B-B14F-4D97-AF65-F5344CB8AC3E}">
@@ -26879,17 +27914,22 @@
           <a:lstStyle/>
           <a:p>
             <a:r>
-              <a:rPr lang="nl-NL"/>
+              <a:rPr lang="nl-NL" dirty="0"/>
               <a:t>Speech </a:t>
             </a:r>
             <a:r>
-              <a:rPr lang="nl-NL" err="1"/>
+              <a:rPr lang="nl-NL" dirty="0" err="1"/>
               <a:t>to</a:t>
             </a:r>
             <a:r>
-              <a:rPr lang="nl-NL"/>
-              <a:t> text</a:t>
+              <a:rPr lang="nl-NL" dirty="0"/>
+              <a:t> </a:t>
             </a:r>
+            <a:r>
+              <a:rPr lang="nl-NL" dirty="0" err="1"/>
+              <a:t>text</a:t>
+            </a:r>
+            <a:endParaRPr lang="nl-NL" dirty="0"/>
           </a:p>
         </p:txBody>
       </p:sp>
@@ -26909,7 +27949,7 @@
             <p:ph idx="1"/>
             <p:extLst>
               <p:ext uri="{D42A27DB-BD31-4B8C-83A1-F6EECF244321}">
-                <p14:modId xmlns:p14="http://schemas.microsoft.com/office/powerpoint/2010/main" val="3530072549"/>
+                <p14:modId xmlns:p14="http://schemas.microsoft.com/office/powerpoint/2010/main" val="4069700763"/>
               </p:ext>
             </p:extLst>
           </p:nvPr>
@@ -26942,7 +27982,9 @@
         </p:nvSpPr>
         <p:spPr/>
         <p:txBody>
-          <a:bodyPr/>
+          <a:bodyPr>
+            <a:normAutofit lnSpcReduction="10000"/>
+          </a:bodyPr>
           <a:lstStyle/>
           <a:p>
             <a:fld id="{75B80215-FF61-4755-832C-0ADA91C81061}" type="slidenum">
@@ -26966,7 +28008,7 @@
           <p:nvPr>
             <p:extLst>
               <p:ext uri="{D42A27DB-BD31-4B8C-83A1-F6EECF244321}">
-                <p14:modId xmlns:p14="http://schemas.microsoft.com/office/powerpoint/2010/main" val="4145611697"/>
+                <p14:modId xmlns:p14="http://schemas.microsoft.com/office/powerpoint/2010/main" val="3728891967"/>
               </p:ext>
             </p:extLst>
           </p:nvPr>
@@ -28010,7 +29052,9 @@
         </p:nvSpPr>
         <p:spPr/>
         <p:txBody>
-          <a:bodyPr/>
+          <a:bodyPr>
+            <a:normAutofit lnSpcReduction="10000"/>
+          </a:bodyPr>
           <a:lstStyle/>
           <a:p>
             <a:fld id="{75B80215-FF61-4755-832C-0ADA91C81061}" type="slidenum">
@@ -28378,23 +29422,6 @@
 </file>
 
 <file path=customXml/item1.xml><?xml version="1.0" encoding="utf-8"?>
-<p:properties xmlns:p="http://schemas.microsoft.com/office/2006/metadata/properties" xmlns:xsi="http://www.w3.org/2001/XMLSchema-instance" xmlns:pc="http://schemas.microsoft.com/office/infopath/2007/PartnerControls">
-  <documentManagement>
-    <_activity xmlns="2f28ad41-d2b5-4b1a-8cf8-df56e9bd2e29" xsi:nil="true"/>
-  </documentManagement>
-</p:properties>
-</file>
-
-<file path=customXml/item2.xml><?xml version="1.0" encoding="utf-8"?>
-<?mso-contentType ?>
-<FormTemplates xmlns="http://schemas.microsoft.com/sharepoint/v3/contenttype/forms">
-  <Display>DocumentLibraryForm</Display>
-  <Edit>DocumentLibraryForm</Edit>
-  <New>DocumentLibraryForm</New>
-</FormTemplates>
-</file>
-
-<file path=customXml/item3.xml><?xml version="1.0" encoding="utf-8"?>
 <ct:contentTypeSchema xmlns:ct="http://schemas.microsoft.com/office/2006/metadata/contentType" xmlns:ma="http://schemas.microsoft.com/office/2006/metadata/properties/metaAttributes" ct:_="" ma:_="" ma:contentTypeName="Document" ma:contentTypeID="0x010100E6E3D6BEA9A96B4CAB483414EB31BDFE" ma:contentTypeVersion="11" ma:contentTypeDescription="Create a new document." ma:contentTypeScope="" ma:versionID="548203ff0093629607d36aec8cb33ed7">
   <xsd:schema xmlns:xsd="http://www.w3.org/2001/XMLSchema" xmlns:xs="http://www.w3.org/2001/XMLSchema" xmlns:p="http://schemas.microsoft.com/office/2006/metadata/properties" xmlns:ns3="2f28ad41-d2b5-4b1a-8cf8-df56e9bd2e29" targetNamespace="http://schemas.microsoft.com/office/2006/metadata/properties" ma:root="true" ma:fieldsID="83c3239bfa9995893806d247b91f406f" ns3:_="">
     <xsd:import namespace="2f28ad41-d2b5-4b1a-8cf8-df56e9bd2e29"/>
@@ -28582,31 +29609,24 @@
 </ct:contentTypeSchema>
 </file>
 
-<file path=customXml/itemProps1.xml><?xml version="1.0" encoding="utf-8"?>
-<ds:datastoreItem xmlns:ds="http://schemas.openxmlformats.org/officeDocument/2006/customXml" ds:itemID="{362A1A3C-237B-4D2C-A885-8996DA8DCD42}">
-  <ds:schemaRefs>
-    <ds:schemaRef ds:uri="http://purl.org/dc/elements/1.1/"/>
-    <ds:schemaRef ds:uri="http://www.w3.org/XML/1998/namespace"/>
-    <ds:schemaRef ds:uri="http://schemas.microsoft.com/office/infopath/2007/PartnerControls"/>
-    <ds:schemaRef ds:uri="http://purl.org/dc/dcmitype/"/>
-    <ds:schemaRef ds:uri="http://schemas.openxmlformats.org/package/2006/metadata/core-properties"/>
-    <ds:schemaRef ds:uri="http://schemas.microsoft.com/office/2006/metadata/properties"/>
-    <ds:schemaRef ds:uri="http://schemas.microsoft.com/office/2006/documentManagement/types"/>
-    <ds:schemaRef ds:uri="http://purl.org/dc/terms/"/>
-    <ds:schemaRef ds:uri="2f28ad41-d2b5-4b1a-8cf8-df56e9bd2e29"/>
-  </ds:schemaRefs>
-</ds:datastoreItem>
+<file path=customXml/item2.xml><?xml version="1.0" encoding="utf-8"?>
+<?mso-contentType ?>
+<FormTemplates xmlns="http://schemas.microsoft.com/sharepoint/v3/contenttype/forms">
+  <Display>DocumentLibraryForm</Display>
+  <Edit>DocumentLibraryForm</Edit>
+  <New>DocumentLibraryForm</New>
+</FormTemplates>
 </file>
 
-<file path=customXml/itemProps2.xml><?xml version="1.0" encoding="utf-8"?>
-<ds:datastoreItem xmlns:ds="http://schemas.openxmlformats.org/officeDocument/2006/customXml" ds:itemID="{50FA316E-6874-4459-A7D9-E901C9D5E03A}">
-  <ds:schemaRefs>
-    <ds:schemaRef ds:uri="http://schemas.microsoft.com/sharepoint/v3/contenttype/forms"/>
-  </ds:schemaRefs>
-</ds:datastoreItem>
+<file path=customXml/item3.xml><?xml version="1.0" encoding="utf-8"?>
+<p:properties xmlns:p="http://schemas.microsoft.com/office/2006/metadata/properties" xmlns:xsi="http://www.w3.org/2001/XMLSchema-instance" xmlns:pc="http://schemas.microsoft.com/office/infopath/2007/PartnerControls">
+  <documentManagement>
+    <_activity xmlns="2f28ad41-d2b5-4b1a-8cf8-df56e9bd2e29" xsi:nil="true"/>
+  </documentManagement>
+</p:properties>
 </file>
 
-<file path=customXml/itemProps3.xml><?xml version="1.0" encoding="utf-8"?>
+<file path=customXml/itemProps1.xml><?xml version="1.0" encoding="utf-8"?>
 <ds:datastoreItem xmlns:ds="http://schemas.openxmlformats.org/officeDocument/2006/customXml" ds:itemID="{EA0E892A-59B6-4D7B-9A7F-762308122AC2}">
   <ds:schemaRefs>
     <ds:schemaRef ds:uri="2f28ad41-d2b5-4b1a-8cf8-df56e9bd2e29"/>
@@ -28622,4 +29642,28 @@
     <ds:schemaRef ds:uri="http://www.w3.org/2001/XMLSchema"/>
   </ds:schemaRefs>
 </ds:datastoreItem>
+</file>
+
+<file path=customXml/itemProps2.xml><?xml version="1.0" encoding="utf-8"?>
+<ds:datastoreItem xmlns:ds="http://schemas.openxmlformats.org/officeDocument/2006/customXml" ds:itemID="{50FA316E-6874-4459-A7D9-E901C9D5E03A}">
+  <ds:schemaRefs>
+    <ds:schemaRef ds:uri="http://schemas.microsoft.com/sharepoint/v3/contenttype/forms"/>
+  </ds:schemaRefs>
+</ds:datastoreItem>
+</file>
+
+<file path=customXml/itemProps3.xml><?xml version="1.0" encoding="utf-8"?>
+<ds:datastoreItem xmlns:ds="http://schemas.openxmlformats.org/officeDocument/2006/customXml" ds:itemID="{362A1A3C-237B-4D2C-A885-8996DA8DCD42}">
+  <ds:schemaRefs>
+    <ds:schemaRef ds:uri="http://purl.org/dc/elements/1.1/"/>
+    <ds:schemaRef ds:uri="http://www.w3.org/XML/1998/namespace"/>
+    <ds:schemaRef ds:uri="http://schemas.microsoft.com/office/infopath/2007/PartnerControls"/>
+    <ds:schemaRef ds:uri="http://purl.org/dc/dcmitype/"/>
+    <ds:schemaRef ds:uri="http://schemas.openxmlformats.org/package/2006/metadata/core-properties"/>
+    <ds:schemaRef ds:uri="http://schemas.microsoft.com/office/2006/metadata/properties"/>
+    <ds:schemaRef ds:uri="http://schemas.microsoft.com/office/2006/documentManagement/types"/>
+    <ds:schemaRef ds:uri="http://purl.org/dc/terms/"/>
+    <ds:schemaRef ds:uri="2f28ad41-d2b5-4b1a-8cf8-df56e9bd2e29"/>
+  </ds:schemaRefs>
+</ds:datastoreItem>
 </file>
</xml_diff>